<commit_message>
feat(delivery+build): stabilité carte, error boundary, migration Artifact Registry
- cloudbuild: migration Container Registry → Artifact Registry (europe-west1)
- EnhancedTrackingMap: onMapReady guard + tracksViewChanges=false sur tous les markers
- DeliveryShoppingTrackingScreen: MapErrorBoundary pour crashs natifs de la carte
- ProgrammeBesoinsSelectorScreen: journeySteps/journeyIndex pour stepper bourse
- notificationSoundService: suppression warmupTTS redondant dans preload/welcome
- fr.json: 2 clés i18n pour blocage édition livraison terminée

Co-Authored-By: Claude Sonnet 4.6 <noreply@anthropic.com>
</commit_message>
<xml_diff>
--- a/Yukpo_Investisseur_Presentation.pptx
+++ b/Yukpo_Investisseur_Presentation.pptx
@@ -421,10 +421,6 @@
         <c:crosses val="autoZero"/>
       </c:valAx>
     </c:plotArea>
-    <c:legend>
-      <c:legendPos val="b"/>
-      <c:overlay val="0"/>
-    </c:legend>
     <c:dispBlanksAs val="gap"/>
   </c:chart>
   <c:txPr>
@@ -18585,6 +18581,237 @@
         </p:nvSpPr>
         <p:spPr>
           <a:xfrm>
+            <a:off x="180000" y="6120000"/>
+            <a:ext cx="198000" cy="162000"/>
+          </a:xfrm>
+          <a:prstGeom prst="rect">
+            <a:avLst/>
+          </a:prstGeom>
+          <a:solidFill>
+            <a:srgbClr val="D4AF37"/>
+          </a:solidFill>
+          <a:ln>
+            <a:noFill/>
+          </a:ln>
+        </p:spPr>
+        <p:style>
+          <a:lnRef idx="1">
+            <a:schemeClr val="accent1"/>
+          </a:lnRef>
+          <a:fillRef idx="3">
+            <a:schemeClr val="accent1"/>
+          </a:fillRef>
+          <a:effectRef idx="2">
+            <a:schemeClr val="accent1"/>
+          </a:effectRef>
+          <a:fontRef idx="minor">
+            <a:schemeClr val="lt1"/>
+          </a:fontRef>
+        </p:style>
+        <p:txBody>
+          <a:bodyPr rtlCol="0" anchor="ctr"/>
+          <a:lstStyle/>
+          <a:p>
+            <a:pPr algn="ctr"/>
+          </a:p>
+        </p:txBody>
+      </p:sp>
+      <p:sp>
+        <p:nvSpPr>
+          <p:cNvPr id="11" name="TextBox 10"/>
+          <p:cNvSpPr txBox="1"/>
+          <p:nvPr/>
+        </p:nvSpPr>
+        <p:spPr>
+          <a:xfrm>
+            <a:off x="414000" y="6120000"/>
+            <a:ext cx="2010000" cy="172800"/>
+          </a:xfrm>
+          <a:prstGeom prst="rect">
+            <a:avLst/>
+          </a:prstGeom>
+          <a:noFill/>
+        </p:spPr>
+        <p:txBody>
+          <a:bodyPr wrap="square">
+            <a:spAutoFit/>
+          </a:bodyPr>
+          <a:lstStyle/>
+          <a:p>
+            <a:pPr algn="l"/>
+            <a:r>
+              <a:rPr sz="1000" b="1" i="0">
+                <a:solidFill>
+                  <a:srgbClr val="FFFFFF"/>
+                </a:solidFill>
+              </a:rPr>
+              <a:t>Revenus (M FCFA)</a:t>
+            </a:r>
+          </a:p>
+        </p:txBody>
+      </p:sp>
+      <p:sp>
+        <p:nvSpPr>
+          <p:cNvPr id="12" name="Rectangle 11"/>
+          <p:cNvSpPr/>
+          <p:nvPr/>
+        </p:nvSpPr>
+        <p:spPr>
+          <a:xfrm>
+            <a:off x="2460000" y="6120000"/>
+            <a:ext cx="198000" cy="162000"/>
+          </a:xfrm>
+          <a:prstGeom prst="rect">
+            <a:avLst/>
+          </a:prstGeom>
+          <a:solidFill>
+            <a:srgbClr val="FF6B6B"/>
+          </a:solidFill>
+          <a:ln>
+            <a:noFill/>
+          </a:ln>
+        </p:spPr>
+        <p:style>
+          <a:lnRef idx="1">
+            <a:schemeClr val="accent1"/>
+          </a:lnRef>
+          <a:fillRef idx="3">
+            <a:schemeClr val="accent1"/>
+          </a:fillRef>
+          <a:effectRef idx="2">
+            <a:schemeClr val="accent1"/>
+          </a:effectRef>
+          <a:fontRef idx="minor">
+            <a:schemeClr val="lt1"/>
+          </a:fontRef>
+        </p:style>
+        <p:txBody>
+          <a:bodyPr rtlCol="0" anchor="ctr"/>
+          <a:lstStyle/>
+          <a:p>
+            <a:pPr algn="ctr"/>
+          </a:p>
+        </p:txBody>
+      </p:sp>
+      <p:sp>
+        <p:nvSpPr>
+          <p:cNvPr id="13" name="TextBox 12"/>
+          <p:cNvSpPr txBox="1"/>
+          <p:nvPr/>
+        </p:nvSpPr>
+        <p:spPr>
+          <a:xfrm>
+            <a:off x="2694000" y="6120000"/>
+            <a:ext cx="2010000" cy="172800"/>
+          </a:xfrm>
+          <a:prstGeom prst="rect">
+            <a:avLst/>
+          </a:prstGeom>
+          <a:noFill/>
+        </p:spPr>
+        <p:txBody>
+          <a:bodyPr wrap="square">
+            <a:spAutoFit/>
+          </a:bodyPr>
+          <a:lstStyle/>
+          <a:p>
+            <a:pPr algn="l"/>
+            <a:r>
+              <a:rPr sz="1000" b="1" i="0">
+                <a:solidFill>
+                  <a:srgbClr val="FFFFFF"/>
+                </a:solidFill>
+              </a:rPr>
+              <a:t>Charges (M FCFA)</a:t>
+            </a:r>
+          </a:p>
+        </p:txBody>
+      </p:sp>
+      <p:sp>
+        <p:nvSpPr>
+          <p:cNvPr id="14" name="Rectangle 13"/>
+          <p:cNvSpPr/>
+          <p:nvPr/>
+        </p:nvSpPr>
+        <p:spPr>
+          <a:xfrm>
+            <a:off x="4740000" y="6120000"/>
+            <a:ext cx="198000" cy="162000"/>
+          </a:xfrm>
+          <a:prstGeom prst="rect">
+            <a:avLst/>
+          </a:prstGeom>
+          <a:solidFill>
+            <a:srgbClr val="4FC3F7"/>
+          </a:solidFill>
+          <a:ln>
+            <a:noFill/>
+          </a:ln>
+        </p:spPr>
+        <p:style>
+          <a:lnRef idx="1">
+            <a:schemeClr val="accent1"/>
+          </a:lnRef>
+          <a:fillRef idx="3">
+            <a:schemeClr val="accent1"/>
+          </a:fillRef>
+          <a:effectRef idx="2">
+            <a:schemeClr val="accent1"/>
+          </a:effectRef>
+          <a:fontRef idx="minor">
+            <a:schemeClr val="lt1"/>
+          </a:fontRef>
+        </p:style>
+        <p:txBody>
+          <a:bodyPr rtlCol="0" anchor="ctr"/>
+          <a:lstStyle/>
+          <a:p>
+            <a:pPr algn="ctr"/>
+          </a:p>
+        </p:txBody>
+      </p:sp>
+      <p:sp>
+        <p:nvSpPr>
+          <p:cNvPr id="15" name="TextBox 14"/>
+          <p:cNvSpPr txBox="1"/>
+          <p:nvPr/>
+        </p:nvSpPr>
+        <p:spPr>
+          <a:xfrm>
+            <a:off x="4974000" y="6120000"/>
+            <a:ext cx="2010000" cy="172800"/>
+          </a:xfrm>
+          <a:prstGeom prst="rect">
+            <a:avLst/>
+          </a:prstGeom>
+          <a:noFill/>
+        </p:spPr>
+        <p:txBody>
+          <a:bodyPr wrap="square">
+            <a:spAutoFit/>
+          </a:bodyPr>
+          <a:lstStyle/>
+          <a:p>
+            <a:pPr algn="l"/>
+            <a:r>
+              <a:rPr sz="1000" b="1" i="0">
+                <a:solidFill>
+                  <a:srgbClr val="FFFFFF"/>
+                </a:solidFill>
+              </a:rPr>
+              <a:t>Trésorerie (M FCFA)</a:t>
+            </a:r>
+          </a:p>
+        </p:txBody>
+      </p:sp>
+      <p:sp>
+        <p:nvSpPr>
+          <p:cNvPr id="16" name="Rectangle 15"/>
+          <p:cNvSpPr/>
+          <p:nvPr/>
+        </p:nvSpPr>
+        <p:spPr>
+          <a:xfrm>
             <a:off x="7343999" y="1440000"/>
             <a:ext cx="1655999" cy="4788000"/>
           </a:xfrm>
@@ -18624,7 +18851,7 @@
       </p:sp>
       <p:sp>
         <p:nvSpPr>
-          <p:cNvPr id="11" name="Rectangle 10"/>
+          <p:cNvPr id="17" name="Rectangle 16"/>
           <p:cNvSpPr/>
           <p:nvPr/>
         </p:nvSpPr>
@@ -18667,7 +18894,7 @@
       </p:sp>
       <p:sp>
         <p:nvSpPr>
-          <p:cNvPr id="12" name="TextBox 11"/>
+          <p:cNvPr id="18" name="TextBox 17"/>
           <p:cNvSpPr txBox="1"/>
           <p:nvPr/>
         </p:nvSpPr>
@@ -18701,7 +18928,7 @@
       </p:sp>
       <p:sp>
         <p:nvSpPr>
-          <p:cNvPr id="13" name="TextBox 12"/>
+          <p:cNvPr id="19" name="TextBox 18"/>
           <p:cNvSpPr txBox="1"/>
           <p:nvPr/>
         </p:nvSpPr>
@@ -18736,7 +18963,7 @@
       </p:sp>
       <p:sp>
         <p:nvSpPr>
-          <p:cNvPr id="14" name="Rectangle 13"/>
+          <p:cNvPr id="20" name="Rectangle 19"/>
           <p:cNvSpPr/>
           <p:nvPr/>
         </p:nvSpPr>
@@ -18779,7 +19006,7 @@
       </p:sp>
       <p:sp>
         <p:nvSpPr>
-          <p:cNvPr id="15" name="TextBox 14"/>
+          <p:cNvPr id="21" name="TextBox 20"/>
           <p:cNvSpPr txBox="1"/>
           <p:nvPr/>
         </p:nvSpPr>
@@ -18813,7 +19040,7 @@
       </p:sp>
       <p:sp>
         <p:nvSpPr>
-          <p:cNvPr id="16" name="TextBox 15"/>
+          <p:cNvPr id="22" name="TextBox 21"/>
           <p:cNvSpPr txBox="1"/>
           <p:nvPr/>
         </p:nvSpPr>
@@ -18847,7 +19074,7 @@
       </p:sp>
       <p:sp>
         <p:nvSpPr>
-          <p:cNvPr id="17" name="Rectangle 16"/>
+          <p:cNvPr id="23" name="Rectangle 22"/>
           <p:cNvSpPr/>
           <p:nvPr/>
         </p:nvSpPr>
@@ -18890,7 +19117,7 @@
       </p:sp>
       <p:sp>
         <p:nvSpPr>
-          <p:cNvPr id="18" name="TextBox 17"/>
+          <p:cNvPr id="24" name="TextBox 23"/>
           <p:cNvSpPr txBox="1"/>
           <p:nvPr/>
         </p:nvSpPr>
@@ -18924,7 +19151,7 @@
       </p:sp>
       <p:sp>
         <p:nvSpPr>
-          <p:cNvPr id="19" name="TextBox 18"/>
+          <p:cNvPr id="25" name="TextBox 24"/>
           <p:cNvSpPr txBox="1"/>
           <p:nvPr/>
         </p:nvSpPr>
@@ -18958,7 +19185,7 @@
       </p:sp>
       <p:sp>
         <p:nvSpPr>
-          <p:cNvPr id="20" name="Rectangle 19"/>
+          <p:cNvPr id="26" name="Rectangle 25"/>
           <p:cNvSpPr/>
           <p:nvPr/>
         </p:nvSpPr>
@@ -19001,7 +19228,7 @@
       </p:sp>
       <p:sp>
         <p:nvSpPr>
-          <p:cNvPr id="21" name="TextBox 20"/>
+          <p:cNvPr id="27" name="TextBox 26"/>
           <p:cNvSpPr txBox="1"/>
           <p:nvPr/>
         </p:nvSpPr>
@@ -19035,7 +19262,7 @@
       </p:sp>
       <p:sp>
         <p:nvSpPr>
-          <p:cNvPr id="22" name="TextBox 21"/>
+          <p:cNvPr id="28" name="TextBox 27"/>
           <p:cNvSpPr txBox="1"/>
           <p:nvPr/>
         </p:nvSpPr>
@@ -19069,7 +19296,7 @@
       </p:sp>
       <p:sp>
         <p:nvSpPr>
-          <p:cNvPr id="23" name="Rectangle 22"/>
+          <p:cNvPr id="29" name="Rectangle 28"/>
           <p:cNvSpPr/>
           <p:nvPr/>
         </p:nvSpPr>
@@ -19112,7 +19339,7 @@
       </p:sp>
       <p:sp>
         <p:nvSpPr>
-          <p:cNvPr id="24" name="TextBox 23"/>
+          <p:cNvPr id="30" name="TextBox 29"/>
           <p:cNvSpPr txBox="1"/>
           <p:nvPr/>
         </p:nvSpPr>
@@ -19146,7 +19373,7 @@
       </p:sp>
       <p:sp>
         <p:nvSpPr>
-          <p:cNvPr id="25" name="TextBox 24"/>
+          <p:cNvPr id="31" name="TextBox 30"/>
           <p:cNvSpPr txBox="1"/>
           <p:nvPr/>
         </p:nvSpPr>
@@ -19180,7 +19407,7 @@
       </p:sp>
       <p:sp>
         <p:nvSpPr>
-          <p:cNvPr id="26" name="Rectangle 25"/>
+          <p:cNvPr id="32" name="Rectangle 31"/>
           <p:cNvSpPr/>
           <p:nvPr/>
         </p:nvSpPr>
@@ -19223,7 +19450,7 @@
       </p:sp>
       <p:sp>
         <p:nvSpPr>
-          <p:cNvPr id="27" name="TextBox 26"/>
+          <p:cNvPr id="33" name="TextBox 32"/>
           <p:cNvSpPr txBox="1"/>
           <p:nvPr/>
         </p:nvSpPr>
@@ -19257,7 +19484,7 @@
       </p:sp>
       <p:sp>
         <p:nvSpPr>
-          <p:cNvPr id="28" name="TextBox 27"/>
+          <p:cNvPr id="34" name="TextBox 33"/>
           <p:cNvSpPr txBox="1"/>
           <p:nvPr/>
         </p:nvSpPr>
@@ -19291,7 +19518,7 @@
       </p:sp>
       <p:sp>
         <p:nvSpPr>
-          <p:cNvPr id="29" name="Rectangle 28"/>
+          <p:cNvPr id="35" name="Rectangle 34"/>
           <p:cNvSpPr/>
           <p:nvPr/>
         </p:nvSpPr>
@@ -19334,7 +19561,7 @@
       </p:sp>
       <p:sp>
         <p:nvSpPr>
-          <p:cNvPr id="30" name="Rectangle 29"/>
+          <p:cNvPr id="36" name="Rectangle 35"/>
           <p:cNvSpPr/>
           <p:nvPr/>
         </p:nvSpPr>
@@ -19379,7 +19606,7 @@
       </p:sp>
       <p:sp>
         <p:nvSpPr>
-          <p:cNvPr id="31" name="TextBox 30"/>
+          <p:cNvPr id="37" name="TextBox 36"/>
           <p:cNvSpPr txBox="1"/>
           <p:nvPr/>
         </p:nvSpPr>
@@ -23661,10 +23888,10 @@
                   <a:srgbClr val="B0C4DE"/>
                 </a:solidFill>
               </a:rPr>
-              <a:t>La banque se porte caution
-pour YUKPO auprès
-de partenaires et
-fournisseurs stratégiques</a:t>
+              <a:t>L'investisseur apporte sa
+caution personnelle à une
+banque, qui octroie en
+retour un prêt à YUKPO.</a:t>
             </a:r>
           </a:p>
         </p:txBody>
@@ -23775,10 +24002,12 @@
                   <a:srgbClr val="B0C4DE"/>
                 </a:solidFill>
               </a:rPr>
-              <a:t>Déblocage de contrats
-commerciaux importants.
-Levier de crédibilité marché
-sans dilution du capital.</a:t>
+              <a:t>YUKPO accède au crédit
+sans diluer son capital.
+L'investisseur valorise
+sa relation bancaire.
+Risque limité si l'activité
+couvre les échéances.</a:t>
             </a:r>
           </a:p>
         </p:txBody>

</xml_diff>